<commit_message>
feat: brand Verity website and embed genuine application screenshots in slides
</commit_message>
<xml_diff>
--- a/output/presentation/Verity_Technical_Presentation.pptx
+++ b/output/presentation/Verity_Technical_Presentation.pptx
@@ -2,24 +2,24 @@
 <file path=ppt/presentation.xml><?xml version="1.0" encoding="utf-8"?>
 <p:presentation xmlns:p="http://schemas.openxmlformats.org/presentationml/2006/main">
   <p:sldMasterIdLst>
-    <p:sldMasterId xmlns:r="http://schemas.openxmlformats.org/officeDocument/2006/relationships" id="2147483648" r:id="Rabd92c2b04c54459"/>
+    <p:sldMasterId xmlns:r="http://schemas.openxmlformats.org/officeDocument/2006/relationships" id="2147483648" r:id="R1f9bc85532154426"/>
   </p:sldMasterIdLst>
   <p:notesMasterIdLst>
-    <p:notesMasterId xmlns:r="http://schemas.openxmlformats.org/officeDocument/2006/relationships" r:id="R4a75417420d74c3a"/>
+    <p:notesMasterId xmlns:r="http://schemas.openxmlformats.org/officeDocument/2006/relationships" r:id="R8a1c4e18494345d1"/>
   </p:notesMasterIdLst>
   <p:sldIdLst>
-    <p:sldId xmlns:r="http://schemas.openxmlformats.org/officeDocument/2006/relationships" id="256" r:id="R33c985e580d54e8f"/>
-    <p:sldId xmlns:r="http://schemas.openxmlformats.org/officeDocument/2006/relationships" id="257" r:id="Rbbdeaad086d146a0"/>
-    <p:sldId xmlns:r="http://schemas.openxmlformats.org/officeDocument/2006/relationships" id="258" r:id="R53ca3c078c8c4cf3"/>
-    <p:sldId xmlns:r="http://schemas.openxmlformats.org/officeDocument/2006/relationships" id="259" r:id="R79694ceaaab34b77"/>
-    <p:sldId xmlns:r="http://schemas.openxmlformats.org/officeDocument/2006/relationships" id="260" r:id="R16900833e6ce4c17"/>
-    <p:sldId xmlns:r="http://schemas.openxmlformats.org/officeDocument/2006/relationships" id="261" r:id="Rd57be022c51a4143"/>
-    <p:sldId xmlns:r="http://schemas.openxmlformats.org/officeDocument/2006/relationships" id="262" r:id="R49f1b80c4fc74018"/>
-    <p:sldId xmlns:r="http://schemas.openxmlformats.org/officeDocument/2006/relationships" id="263" r:id="Rf74dbd2be7824d9f"/>
-    <p:sldId xmlns:r="http://schemas.openxmlformats.org/officeDocument/2006/relationships" id="264" r:id="R31af4f6b173e4047"/>
-    <p:sldId xmlns:r="http://schemas.openxmlformats.org/officeDocument/2006/relationships" id="265" r:id="Rd898c9bdba964839"/>
-    <p:sldId xmlns:r="http://schemas.openxmlformats.org/officeDocument/2006/relationships" id="266" r:id="R4ba2e6c1d4994372"/>
-    <p:sldId xmlns:r="http://schemas.openxmlformats.org/officeDocument/2006/relationships" id="267" r:id="R6f4a968e2faa4577"/>
+    <p:sldId xmlns:r="http://schemas.openxmlformats.org/officeDocument/2006/relationships" id="256" r:id="R5fbde3d7de494e9c"/>
+    <p:sldId xmlns:r="http://schemas.openxmlformats.org/officeDocument/2006/relationships" id="257" r:id="Rbb65c95745984bd6"/>
+    <p:sldId xmlns:r="http://schemas.openxmlformats.org/officeDocument/2006/relationships" id="258" r:id="R83d1d72177dd4f96"/>
+    <p:sldId xmlns:r="http://schemas.openxmlformats.org/officeDocument/2006/relationships" id="259" r:id="Racd0ed3e427f4000"/>
+    <p:sldId xmlns:r="http://schemas.openxmlformats.org/officeDocument/2006/relationships" id="260" r:id="Rb45dfa65fe6645a7"/>
+    <p:sldId xmlns:r="http://schemas.openxmlformats.org/officeDocument/2006/relationships" id="261" r:id="R1d92c8e8ad0f458c"/>
+    <p:sldId xmlns:r="http://schemas.openxmlformats.org/officeDocument/2006/relationships" id="262" r:id="R0600eedabc634adb"/>
+    <p:sldId xmlns:r="http://schemas.openxmlformats.org/officeDocument/2006/relationships" id="263" r:id="R977bc86b625f4236"/>
+    <p:sldId xmlns:r="http://schemas.openxmlformats.org/officeDocument/2006/relationships" id="264" r:id="Rfbc538a72eaa4f60"/>
+    <p:sldId xmlns:r="http://schemas.openxmlformats.org/officeDocument/2006/relationships" id="265" r:id="R912acbf4733b4e49"/>
+    <p:sldId xmlns:r="http://schemas.openxmlformats.org/officeDocument/2006/relationships" id="266" r:id="R0f1f31a9e12141fe"/>
+    <p:sldId xmlns:r="http://schemas.openxmlformats.org/officeDocument/2006/relationships" id="267" r:id="R04a74104ec354003"/>
   </p:sldIdLst>
   <p:sldSz cx="12192000" cy="6858000"/>
   <p:notesSz cx="6858000" cy="9144000"/>
@@ -758,7 +758,7 @@
           </a:p>
           <a:p xmlns:a="http://schemas.openxmlformats.org/drawingml/2006/main">
             <a:r>
-              <a:t>The completed website supports chat, explicit approval, conflict resolution, historical comparison and rollback. The finite India application workload produced fourteen correct neural answers and passed twelve provenance and transaction consistency checks. It represents one fictional display lineage and remains separate from held out accuracy. Our contribution is the governed application, versioned memory, retrieval adaptation, independent datasets and reproducible evaluation. The upstream authors supply the learned checkpoint and training. The evidence supports this system's defined short factual contract under the tested conditions. Larger memories, ambiguous scopes, missing evidence and independently reviewed operational language need further validation. We can now demonstrate a correction and its reversal. Thank you.</a:t>
+              <a:t>The completed website supports chat, explicit approval, conflict resolution, historical comparison and rollback. The screenshot displays a saved three hop answer after rollback, rather than a fresh generation. The finite India application workload produced fourteen correct neural answers and passed twelve provenance and transaction consistency checks. It represents one fictional display lineage and remains separate from held out accuracy. Our contribution is the governed application, versioned memory, retrieval adaptation, independent datasets and reproducible evaluation. The upstream authors supply the learned checkpoint and training. The evidence supports this system's defined short factual contract under the tested conditions. Larger memories, ambiguous scopes, missing evidence and independently reviewed operational language need further validation. We can now demonstrate a correction and its reversal. Thank you.</a:t>
             </a:r>
           </a:p>
           <a:p xmlns:a="http://schemas.openxmlformats.org/drawingml/2006/main">
@@ -778,12 +778,17 @@
           </a:p>
           <a:p xmlns:a="http://schemas.openxmlformats.org/drawingml/2006/main">
             <a:r>
-              <a:t>https://github.com/ShivamRaghav7/verity/tree/ae7bb2010a82fd1d744d008eb7c6f870198aece5/reports/reasonke/depth-final/india-host-audit.json</a:t>
+              <a:t>https://github.com/ShivamRaghav7/verity/tree/ae7bb2010a82fd1d744d008eb7c6f870198aece5/docs/CONTRIBUTIONS_AND_EVIDENCE.md</a:t>
             </a:r>
           </a:p>
           <a:p xmlns:a="http://schemas.openxmlformats.org/drawingml/2006/main">
             <a:r>
-              <a:t>https://github.com/ShivamRaghav7/verity/tree/ae7bb2010a82fd1d744d008eb7c6f870198aece5/docs/CONTRIBUTIONS_AND_EVIDENCE.md</a:t>
+              <a:t>Screenshots: actual local Verity website, captured 2026-10-30. The screenshot workspace restores saved India acceptance responses, not new inference. The worker status remains unavailable.</a:t>
+            </a:r>
+          </a:p>
+          <a:p xmlns:a="http://schemas.openxmlformats.org/drawingml/2006/main">
+            <a:r>
+              <a:t>https://github.com/ShivamRaghav7/verity/blob/codex/reasonke-integration/output/presentation/screenshots/provenance.json</a:t>
             </a:r>
           </a:p>
         </p:txBody>
@@ -1303,7 +1308,12 @@
           </a:p>
           <a:p xmlns:a="http://schemas.openxmlformats.org/drawingml/2006/main">
             <a:r>
-              <a:t>https://github.com/ShivamRaghav7/verity/tree/ae7bb2010a82fd1d744d008eb7c6f870198aece5/tests/test_chat_store.py</a:t>
+              <a:t>Screenshots: actual local Verity website, captured 2026-10-30. The screenshot workspace restores saved India acceptance responses, not new inference. The worker status remains unavailable.</a:t>
+            </a:r>
+          </a:p>
+          <a:p xmlns:a="http://schemas.openxmlformats.org/drawingml/2006/main">
+            <a:r>
+              <a:t>https://github.com/ShivamRaghav7/verity/blob/codex/reasonke-integration/output/presentation/screenshots/provenance.json</a:t>
             </a:r>
           </a:p>
         </p:txBody>
@@ -4051,12 +4061,12 @@
   </p:cSld>
   <p:clrMap bg1="lt1" tx1="dk1" bg2="lt2" tx2="dk2" accent1="accent1" accent2="accent2" accent3="accent3" accent4="accent4" accent5="accent5" accent6="accent6" hlink="hlink" folHlink="folHlink"/>
   <p:sldLayoutIdLst>
-    <p:sldLayoutId xmlns:r="http://schemas.openxmlformats.org/officeDocument/2006/relationships" id="2147483649" r:id="Rb3f2138bb86f4794"/>
-    <p:sldLayoutId xmlns:r="http://schemas.openxmlformats.org/officeDocument/2006/relationships" id="2147483650" r:id="R2a0a00b61a364987"/>
-    <p:sldLayoutId xmlns:r="http://schemas.openxmlformats.org/officeDocument/2006/relationships" id="2147483651" r:id="Rab44fabbd0034c37"/>
-    <p:sldLayoutId xmlns:r="http://schemas.openxmlformats.org/officeDocument/2006/relationships" id="2147483652" r:id="Rd28dc56553424fb9"/>
-    <p:sldLayoutId xmlns:r="http://schemas.openxmlformats.org/officeDocument/2006/relationships" id="2147483653" r:id="R56fc78a0f2c14075"/>
-    <p:sldLayoutId xmlns:r="http://schemas.openxmlformats.org/officeDocument/2006/relationships" id="2147483654" r:id="Rc408fb2e947f4c83"/>
+    <p:sldLayoutId xmlns:r="http://schemas.openxmlformats.org/officeDocument/2006/relationships" id="2147483649" r:id="R3ca048c0935e4367"/>
+    <p:sldLayoutId xmlns:r="http://schemas.openxmlformats.org/officeDocument/2006/relationships" id="2147483650" r:id="R71444271c8bd4fa4"/>
+    <p:sldLayoutId xmlns:r="http://schemas.openxmlformats.org/officeDocument/2006/relationships" id="2147483651" r:id="Rb7ee93ee86fe45db"/>
+    <p:sldLayoutId xmlns:r="http://schemas.openxmlformats.org/officeDocument/2006/relationships" id="2147483652" r:id="R5d958cb20e1a4ee3"/>
+    <p:sldLayoutId xmlns:r="http://schemas.openxmlformats.org/officeDocument/2006/relationships" id="2147483653" r:id="R34c6351bf63b43b3"/>
+    <p:sldLayoutId xmlns:r="http://schemas.openxmlformats.org/officeDocument/2006/relationships" id="2147483654" r:id="R25bb39e10757407e"/>
   </p:sldLayoutIdLst>
   <p:txStyles>
     <p:titleStyle>
@@ -6325,7 +6335,7 @@
         </p:xfrm>
         <a:graphic xmlns:a="http://schemas.openxmlformats.org/drawingml/2006/main">
           <a:graphicData uri="http://schemas.openxmlformats.org/drawingml/2006/chart">
-            <c:chart xmlns:r="http://schemas.openxmlformats.org/officeDocument/2006/relationships" xmlns:c="http://schemas.openxmlformats.org/drawingml/2006/chart" r:id="Rdf679ecf8d7c45e4"/>
+            <c:chart xmlns:r="http://schemas.openxmlformats.org/officeDocument/2006/relationships" xmlns:c="http://schemas.openxmlformats.org/drawingml/2006/chart" r:id="R79aee9b5dec445d7"/>
           </a:graphicData>
         </a:graphic>
       </p:graphicFrame>
@@ -8865,8 +8875,8 @@
         </p:nvSpPr>
         <p:spPr>
           <a:xfrm xmlns:a="http://schemas.openxmlformats.org/drawingml/2006/main">
-            <a:off x="647700" y="1695450"/>
-            <a:ext cx="10572750" cy="428625"/>
+            <a:off x="647700" y="1685925"/>
+            <a:ext cx="3095625" cy="457200"/>
           </a:xfrm>
           <a:prstGeom xmlns:a="http://schemas.openxmlformats.org/drawingml/2006/main" prst="rect">
             <a:avLst/>
@@ -8882,7 +8892,7 @@
           </a:bodyPr>
           <a:lstStyle xmlns:a="http://schemas.openxmlformats.org/drawingml/2006/main">
             <a:defPPr>
-              <a:defRPr sz="2475" b="1">
+              <a:defRPr sz="2250" b="1">
                 <a:solidFill>
                   <a:srgbClr val="26766D"/>
                 </a:solidFill>
@@ -8892,7 +8902,7 @@
               </a:defRPr>
             </a:defPPr>
             <a:lvl1pPr>
-              <a:defRPr sz="2475" b="1">
+              <a:defRPr sz="2250" b="1">
                 <a:solidFill>
                   <a:srgbClr val="26766D"/>
                 </a:solidFill>
@@ -8902,7 +8912,7 @@
               </a:defRPr>
             </a:lvl1pPr>
             <a:lvl2pPr>
-              <a:defRPr sz="2475" b="1">
+              <a:defRPr sz="2250" b="1">
                 <a:solidFill>
                   <a:srgbClr val="26766D"/>
                 </a:solidFill>
@@ -8912,7 +8922,7 @@
               </a:defRPr>
             </a:lvl2pPr>
             <a:lvl3pPr>
-              <a:defRPr sz="2475" b="1">
+              <a:defRPr sz="2250" b="1">
                 <a:solidFill>
                   <a:srgbClr val="26766D"/>
                 </a:solidFill>
@@ -8922,7 +8932,7 @@
               </a:defRPr>
             </a:lvl3pPr>
             <a:lvl4pPr>
-              <a:defRPr sz="2475" b="1">
+              <a:defRPr sz="2250" b="1">
                 <a:solidFill>
                   <a:srgbClr val="26766D"/>
                 </a:solidFill>
@@ -8932,7 +8942,7 @@
               </a:defRPr>
             </a:lvl4pPr>
             <a:lvl5pPr>
-              <a:defRPr sz="2475" b="1">
+              <a:defRPr sz="2250" b="1">
                 <a:solidFill>
                   <a:srgbClr val="26766D"/>
                 </a:solidFill>
@@ -8942,7 +8952,7 @@
               </a:defRPr>
             </a:lvl5pPr>
             <a:lvl6pPr>
-              <a:defRPr sz="2475" b="1">
+              <a:defRPr sz="2250" b="1">
                 <a:solidFill>
                   <a:srgbClr val="26766D"/>
                 </a:solidFill>
@@ -8952,7 +8962,7 @@
               </a:defRPr>
             </a:lvl6pPr>
             <a:lvl7pPr>
-              <a:defRPr sz="2475" b="1">
+              <a:defRPr sz="2250" b="1">
                 <a:solidFill>
                   <a:srgbClr val="26766D"/>
                 </a:solidFill>
@@ -8962,7 +8972,7 @@
               </a:defRPr>
             </a:lvl7pPr>
             <a:lvl8pPr>
-              <a:defRPr sz="2475" b="1">
+              <a:defRPr sz="2250" b="1">
                 <a:solidFill>
                   <a:srgbClr val="26766D"/>
                 </a:solidFill>
@@ -8972,7 +8982,7 @@
               </a:defRPr>
             </a:lvl8pPr>
             <a:lvl9pPr>
-              <a:defRPr sz="2475" b="1">
+              <a:defRPr sz="2250" b="1">
                 <a:solidFill>
                   <a:srgbClr val="26766D"/>
                 </a:solidFill>
@@ -8984,7 +8994,7 @@
           </a:lstStyle>
           <a:p xmlns:a="http://schemas.openxmlformats.org/drawingml/2006/main">
             <a:pPr>
-              <a:defRPr sz="2475" b="1">
+              <a:defRPr sz="2250" b="1">
                 <a:solidFill>
                   <a:srgbClr val="26766D"/>
                 </a:solidFill>
@@ -8994,7 +9004,7 @@
               </a:defRPr>
             </a:pPr>
             <a:r>
-              <a:rPr sz="2475" b="1">
+              <a:rPr sz="2250" b="1">
                 <a:solidFill>
                   <a:srgbClr val="26766D"/>
                 </a:solidFill>
@@ -9002,7 +9012,7 @@
                 <a:ea typeface="Calibri"/>
                 <a:cs typeface="Calibri"/>
               </a:rPr>
-              <a:t>Measured correction workflow</a:t>
+              <a:t>Measured workflow</a:t>
             </a:r>
           </a:p>
         </p:txBody>
@@ -9023,8 +9033,8 @@
         </p:nvSpPr>
         <p:spPr>
           <a:xfrm xmlns:a="http://schemas.openxmlformats.org/drawingml/2006/main">
-            <a:off x="647700" y="2314575"/>
-            <a:ext cx="10715625" cy="1028700"/>
+            <a:off x="647700" y="2333625"/>
+            <a:ext cx="3095625" cy="2228850"/>
           </a:xfrm>
           <a:prstGeom xmlns:a="http://schemas.openxmlformats.org/drawingml/2006/main" prst="rect">
             <a:avLst/>
@@ -9040,7 +9050,7 @@
           </a:bodyPr>
           <a:lstStyle xmlns:a="http://schemas.openxmlformats.org/drawingml/2006/main">
             <a:defPPr>
-              <a:defRPr sz="2175" b="0">
+              <a:defRPr sz="2025" b="0">
                 <a:solidFill>
                   <a:srgbClr val="152B2B"/>
                 </a:solidFill>
@@ -9050,7 +9060,7 @@
               </a:defRPr>
             </a:defPPr>
             <a:lvl1pPr>
-              <a:defRPr sz="2175" b="0">
+              <a:defRPr sz="2025" b="0">
                 <a:solidFill>
                   <a:srgbClr val="152B2B"/>
                 </a:solidFill>
@@ -9060,7 +9070,7 @@
               </a:defRPr>
             </a:lvl1pPr>
             <a:lvl2pPr>
-              <a:defRPr sz="2175" b="0">
+              <a:defRPr sz="2025" b="0">
                 <a:solidFill>
                   <a:srgbClr val="152B2B"/>
                 </a:solidFill>
@@ -9070,7 +9080,7 @@
               </a:defRPr>
             </a:lvl2pPr>
             <a:lvl3pPr>
-              <a:defRPr sz="2175" b="0">
+              <a:defRPr sz="2025" b="0">
                 <a:solidFill>
                   <a:srgbClr val="152B2B"/>
                 </a:solidFill>
@@ -9080,7 +9090,7 @@
               </a:defRPr>
             </a:lvl3pPr>
             <a:lvl4pPr>
-              <a:defRPr sz="2175" b="0">
+              <a:defRPr sz="2025" b="0">
                 <a:solidFill>
                   <a:srgbClr val="152B2B"/>
                 </a:solidFill>
@@ -9090,7 +9100,7 @@
               </a:defRPr>
             </a:lvl4pPr>
             <a:lvl5pPr>
-              <a:defRPr sz="2175" b="0">
+              <a:defRPr sz="2025" b="0">
                 <a:solidFill>
                   <a:srgbClr val="152B2B"/>
                 </a:solidFill>
@@ -9100,7 +9110,7 @@
               </a:defRPr>
             </a:lvl5pPr>
             <a:lvl6pPr>
-              <a:defRPr sz="2175" b="0">
+              <a:defRPr sz="2025" b="0">
                 <a:solidFill>
                   <a:srgbClr val="152B2B"/>
                 </a:solidFill>
@@ -9110,7 +9120,7 @@
               </a:defRPr>
             </a:lvl6pPr>
             <a:lvl7pPr>
-              <a:defRPr sz="2175" b="0">
+              <a:defRPr sz="2025" b="0">
                 <a:solidFill>
                   <a:srgbClr val="152B2B"/>
                 </a:solidFill>
@@ -9120,7 +9130,7 @@
               </a:defRPr>
             </a:lvl7pPr>
             <a:lvl8pPr>
-              <a:defRPr sz="2175" b="0">
+              <a:defRPr sz="2025" b="0">
                 <a:solidFill>
                   <a:srgbClr val="152B2B"/>
                 </a:solidFill>
@@ -9130,7 +9140,7 @@
               </a:defRPr>
             </a:lvl8pPr>
             <a:lvl9pPr>
-              <a:defRPr sz="2175" b="0">
+              <a:defRPr sz="2025" b="0">
                 <a:solidFill>
                   <a:srgbClr val="152B2B"/>
                 </a:solidFill>
@@ -9142,7 +9152,7 @@
           </a:lstStyle>
           <a:p xmlns:a="http://schemas.openxmlformats.org/drawingml/2006/main">
             <a:pPr>
-              <a:defRPr sz="2175" b="0">
+              <a:defRPr sz="2025" b="0">
                 <a:solidFill>
                   <a:srgbClr val="152B2B"/>
                 </a:solidFill>
@@ -9152,7 +9162,7 @@
               </a:defRPr>
             </a:pPr>
             <a:r>
-              <a:rPr sz="2175" b="0">
+              <a:rPr sz="2025" b="0">
                 <a:solidFill>
                   <a:srgbClr val="152B2B"/>
                 </a:solidFill>
@@ -9160,7 +9170,53 @@
                 <a:ea typeface="Calibri"/>
                 <a:cs typeface="Calibri"/>
               </a:rPr>
-              <a:t>Initial memory r9. Ownership replacement r10. Atomic rollback r11.</a:t>
+              <a:t>r9  Initial memory</a:t>
+            </a:r>
+          </a:p>
+          <a:p xmlns:a="http://schemas.openxmlformats.org/drawingml/2006/main">
+            <a:pPr>
+              <a:defRPr sz="2025" b="0">
+                <a:solidFill>
+                  <a:srgbClr val="152B2B"/>
+                </a:solidFill>
+                <a:latin typeface="Calibri"/>
+                <a:ea typeface="Calibri"/>
+                <a:cs typeface="Calibri"/>
+              </a:defRPr>
+            </a:pPr>
+            <a:r>
+              <a:rPr sz="2025" b="0">
+                <a:solidFill>
+                  <a:srgbClr val="152B2B"/>
+                </a:solidFill>
+                <a:latin typeface="Calibri"/>
+                <a:ea typeface="Calibri"/>
+                <a:cs typeface="Calibri"/>
+              </a:rPr>
+              <a:t>r10  Ownership edit</a:t>
+            </a:r>
+          </a:p>
+          <a:p xmlns:a="http://schemas.openxmlformats.org/drawingml/2006/main">
+            <a:pPr>
+              <a:defRPr sz="2025" b="0">
+                <a:solidFill>
+                  <a:srgbClr val="152B2B"/>
+                </a:solidFill>
+                <a:latin typeface="Calibri"/>
+                <a:ea typeface="Calibri"/>
+                <a:cs typeface="Calibri"/>
+              </a:defRPr>
+            </a:pPr>
+            <a:r>
+              <a:rPr sz="2025" b="0">
+                <a:solidFill>
+                  <a:srgbClr val="152B2B"/>
+                </a:solidFill>
+                <a:latin typeface="Calibri"/>
+                <a:ea typeface="Calibri"/>
+                <a:cs typeface="Calibri"/>
+              </a:rPr>
+              <a:t>r11  Atomic rollback</a:t>
             </a:r>
           </a:p>
           <a:p xmlns:a="http://schemas.openxmlformats.org/drawingml/2006/main">
@@ -9183,7 +9239,53 @@
                 <a:ea typeface="Calibri"/>
                 <a:cs typeface="Calibri"/>
               </a:rPr>
-              <a:t>14/14 actual model answers and 12 consistency checks passed.</a:t>
+              <a:t/>
+            </a:r>
+          </a:p>
+          <a:p xmlns:a="http://schemas.openxmlformats.org/drawingml/2006/main">
+            <a:pPr>
+              <a:defRPr sz="2025" b="0">
+                <a:solidFill>
+                  <a:srgbClr val="152B2B"/>
+                </a:solidFill>
+                <a:latin typeface="Calibri"/>
+                <a:ea typeface="Calibri"/>
+                <a:cs typeface="Calibri"/>
+              </a:defRPr>
+            </a:pPr>
+            <a:r>
+              <a:rPr sz="2025" b="0">
+                <a:solidFill>
+                  <a:srgbClr val="152B2B"/>
+                </a:solidFill>
+                <a:latin typeface="Calibri"/>
+                <a:ea typeface="Calibri"/>
+                <a:cs typeface="Calibri"/>
+              </a:rPr>
+              <a:t>14/14 neural answers</a:t>
+            </a:r>
+          </a:p>
+          <a:p xmlns:a="http://schemas.openxmlformats.org/drawingml/2006/main">
+            <a:pPr>
+              <a:defRPr sz="2025" b="0">
+                <a:solidFill>
+                  <a:srgbClr val="152B2B"/>
+                </a:solidFill>
+                <a:latin typeface="Calibri"/>
+                <a:ea typeface="Calibri"/>
+                <a:cs typeface="Calibri"/>
+              </a:defRPr>
+            </a:pPr>
+            <a:r>
+              <a:rPr sz="2025" b="0">
+                <a:solidFill>
+                  <a:srgbClr val="152B2B"/>
+                </a:solidFill>
+                <a:latin typeface="Calibri"/>
+                <a:ea typeface="Calibri"/>
+                <a:cs typeface="Calibri"/>
+              </a:rPr>
+              <a:t>12 consistency checks</a:t>
             </a:r>
           </a:p>
         </p:txBody>
@@ -9204,8 +9306,8 @@
         </p:nvSpPr>
         <p:spPr>
           <a:xfrm xmlns:a="http://schemas.openxmlformats.org/drawingml/2006/main">
-            <a:off x="647700" y="3752850"/>
-            <a:ext cx="10572750" cy="428625"/>
+            <a:off x="647700" y="4676775"/>
+            <a:ext cx="3095625" cy="409575"/>
           </a:xfrm>
           <a:prstGeom xmlns:a="http://schemas.openxmlformats.org/drawingml/2006/main" prst="rect">
             <a:avLst/>
@@ -9221,7 +9323,7 @@
           </a:bodyPr>
           <a:lstStyle xmlns:a="http://schemas.openxmlformats.org/drawingml/2006/main">
             <a:defPPr>
-              <a:defRPr sz="2475" b="1">
+              <a:defRPr sz="2175" b="1">
                 <a:solidFill>
                   <a:srgbClr val="152B2B"/>
                 </a:solidFill>
@@ -9231,7 +9333,7 @@
               </a:defRPr>
             </a:defPPr>
             <a:lvl1pPr>
-              <a:defRPr sz="2475" b="1">
+              <a:defRPr sz="2175" b="1">
                 <a:solidFill>
                   <a:srgbClr val="152B2B"/>
                 </a:solidFill>
@@ -9241,7 +9343,7 @@
               </a:defRPr>
             </a:lvl1pPr>
             <a:lvl2pPr>
-              <a:defRPr sz="2475" b="1">
+              <a:defRPr sz="2175" b="1">
                 <a:solidFill>
                   <a:srgbClr val="152B2B"/>
                 </a:solidFill>
@@ -9251,7 +9353,7 @@
               </a:defRPr>
             </a:lvl2pPr>
             <a:lvl3pPr>
-              <a:defRPr sz="2475" b="1">
+              <a:defRPr sz="2175" b="1">
                 <a:solidFill>
                   <a:srgbClr val="152B2B"/>
                 </a:solidFill>
@@ -9261,7 +9363,7 @@
               </a:defRPr>
             </a:lvl3pPr>
             <a:lvl4pPr>
-              <a:defRPr sz="2475" b="1">
+              <a:defRPr sz="2175" b="1">
                 <a:solidFill>
                   <a:srgbClr val="152B2B"/>
                 </a:solidFill>
@@ -9271,7 +9373,7 @@
               </a:defRPr>
             </a:lvl4pPr>
             <a:lvl5pPr>
-              <a:defRPr sz="2475" b="1">
+              <a:defRPr sz="2175" b="1">
                 <a:solidFill>
                   <a:srgbClr val="152B2B"/>
                 </a:solidFill>
@@ -9281,7 +9383,7 @@
               </a:defRPr>
             </a:lvl5pPr>
             <a:lvl6pPr>
-              <a:defRPr sz="2475" b="1">
+              <a:defRPr sz="2175" b="1">
                 <a:solidFill>
                   <a:srgbClr val="152B2B"/>
                 </a:solidFill>
@@ -9291,7 +9393,7 @@
               </a:defRPr>
             </a:lvl6pPr>
             <a:lvl7pPr>
-              <a:defRPr sz="2475" b="1">
+              <a:defRPr sz="2175" b="1">
                 <a:solidFill>
                   <a:srgbClr val="152B2B"/>
                 </a:solidFill>
@@ -9301,7 +9403,7 @@
               </a:defRPr>
             </a:lvl7pPr>
             <a:lvl8pPr>
-              <a:defRPr sz="2475" b="1">
+              <a:defRPr sz="2175" b="1">
                 <a:solidFill>
                   <a:srgbClr val="152B2B"/>
                 </a:solidFill>
@@ -9311,7 +9413,7 @@
               </a:defRPr>
             </a:lvl8pPr>
             <a:lvl9pPr>
-              <a:defRPr sz="2475" b="1">
+              <a:defRPr sz="2175" b="1">
                 <a:solidFill>
                   <a:srgbClr val="152B2B"/>
                 </a:solidFill>
@@ -9323,7 +9425,7 @@
           </a:lstStyle>
           <a:p xmlns:a="http://schemas.openxmlformats.org/drawingml/2006/main">
             <a:pPr>
-              <a:defRPr sz="2475" b="1">
+              <a:defRPr sz="2175" b="1">
                 <a:solidFill>
                   <a:srgbClr val="152B2B"/>
                 </a:solidFill>
@@ -9333,7 +9435,7 @@
               </a:defRPr>
             </a:pPr>
             <a:r>
-              <a:rPr sz="2475" b="1">
+              <a:rPr sz="2175" b="1">
                 <a:solidFill>
                   <a:srgbClr val="152B2B"/>
                 </a:solidFill>
@@ -9341,7 +9443,7 @@
                 <a:ea typeface="Calibri"/>
                 <a:cs typeface="Calibri"/>
               </a:rPr>
-              <a:t>Engineering contribution</a:t>
+              <a:t>Our contribution</a:t>
             </a:r>
           </a:p>
         </p:txBody>
@@ -9362,8 +9464,8 @@
         </p:nvSpPr>
         <p:spPr>
           <a:xfrm xmlns:a="http://schemas.openxmlformats.org/drawingml/2006/main">
-            <a:off x="647700" y="4333875"/>
-            <a:ext cx="10715625" cy="1047750"/>
+            <a:off x="647700" y="5191125"/>
+            <a:ext cx="3095625" cy="847725"/>
           </a:xfrm>
           <a:prstGeom xmlns:a="http://schemas.openxmlformats.org/drawingml/2006/main" prst="rect">
             <a:avLst/>
@@ -9379,7 +9481,7 @@
           </a:bodyPr>
           <a:lstStyle xmlns:a="http://schemas.openxmlformats.org/drawingml/2006/main">
             <a:defPPr>
-              <a:defRPr sz="2100" b="0">
+              <a:defRPr sz="1800" b="0">
                 <a:solidFill>
                   <a:srgbClr val="152B2B"/>
                 </a:solidFill>
@@ -9389,7 +9491,7 @@
               </a:defRPr>
             </a:defPPr>
             <a:lvl1pPr>
-              <a:defRPr sz="2100" b="0">
+              <a:defRPr sz="1800" b="0">
                 <a:solidFill>
                   <a:srgbClr val="152B2B"/>
                 </a:solidFill>
@@ -9399,7 +9501,7 @@
               </a:defRPr>
             </a:lvl1pPr>
             <a:lvl2pPr>
-              <a:defRPr sz="2100" b="0">
+              <a:defRPr sz="1800" b="0">
                 <a:solidFill>
                   <a:srgbClr val="152B2B"/>
                 </a:solidFill>
@@ -9409,7 +9511,7 @@
               </a:defRPr>
             </a:lvl2pPr>
             <a:lvl3pPr>
-              <a:defRPr sz="2100" b="0">
+              <a:defRPr sz="1800" b="0">
                 <a:solidFill>
                   <a:srgbClr val="152B2B"/>
                 </a:solidFill>
@@ -9419,7 +9521,7 @@
               </a:defRPr>
             </a:lvl3pPr>
             <a:lvl4pPr>
-              <a:defRPr sz="2100" b="0">
+              <a:defRPr sz="1800" b="0">
                 <a:solidFill>
                   <a:srgbClr val="152B2B"/>
                 </a:solidFill>
@@ -9429,7 +9531,7 @@
               </a:defRPr>
             </a:lvl4pPr>
             <a:lvl5pPr>
-              <a:defRPr sz="2100" b="0">
+              <a:defRPr sz="1800" b="0">
                 <a:solidFill>
                   <a:srgbClr val="152B2B"/>
                 </a:solidFill>
@@ -9439,7 +9541,7 @@
               </a:defRPr>
             </a:lvl5pPr>
             <a:lvl6pPr>
-              <a:defRPr sz="2100" b="0">
+              <a:defRPr sz="1800" b="0">
                 <a:solidFill>
                   <a:srgbClr val="152B2B"/>
                 </a:solidFill>
@@ -9449,7 +9551,7 @@
               </a:defRPr>
             </a:lvl6pPr>
             <a:lvl7pPr>
-              <a:defRPr sz="2100" b="0">
+              <a:defRPr sz="1800" b="0">
                 <a:solidFill>
                   <a:srgbClr val="152B2B"/>
                 </a:solidFill>
@@ -9459,7 +9561,7 @@
               </a:defRPr>
             </a:lvl7pPr>
             <a:lvl8pPr>
-              <a:defRPr sz="2100" b="0">
+              <a:defRPr sz="1800" b="0">
                 <a:solidFill>
                   <a:srgbClr val="152B2B"/>
                 </a:solidFill>
@@ -9469,7 +9571,7 @@
               </a:defRPr>
             </a:lvl8pPr>
             <a:lvl9pPr>
-              <a:defRPr sz="2100" b="0">
+              <a:defRPr sz="1800" b="0">
                 <a:solidFill>
                   <a:srgbClr val="152B2B"/>
                 </a:solidFill>
@@ -9481,7 +9583,7 @@
           </a:lstStyle>
           <a:p xmlns:a="http://schemas.openxmlformats.org/drawingml/2006/main">
             <a:pPr>
-              <a:defRPr sz="2100" b="0">
+              <a:defRPr sz="1800" b="0">
                 <a:solidFill>
                   <a:srgbClr val="152B2B"/>
                 </a:solidFill>
@@ -9491,7 +9593,7 @@
               </a:defRPr>
             </a:pPr>
             <a:r>
-              <a:rPr sz="2100" b="0">
+              <a:rPr sz="1800" b="0">
                 <a:solidFill>
                   <a:srgbClr val="152B2B"/>
                 </a:solidFill>
@@ -9499,12 +9601,12 @@
                 <a:ea typeface="Calibri"/>
                 <a:cs typeface="Calibri"/>
               </a:rPr>
-              <a:t>Versioned memory and history, context selection adaptations, independent data,</a:t>
+              <a:t>Governed memory, retrieval,</a:t>
             </a:r>
           </a:p>
           <a:p xmlns:a="http://schemas.openxmlformats.org/drawingml/2006/main">
             <a:pPr>
-              <a:defRPr sz="2100" b="0">
+              <a:defRPr sz="1800" b="0">
                 <a:solidFill>
                   <a:srgbClr val="152B2B"/>
                 </a:solidFill>
@@ -9514,7 +9616,7 @@
               </a:defRPr>
             </a:pPr>
             <a:r>
-              <a:rPr sz="2100" b="0">
+              <a:rPr sz="1800" b="0">
                 <a:solidFill>
                   <a:srgbClr val="152B2B"/>
                 </a:solidFill>
@@ -9522,7 +9624,30 @@
                 <a:ea typeface="Calibri"/>
                 <a:cs typeface="Calibri"/>
               </a:rPr>
-              <a:t>finite matched evaluation, raw output audits and an inspectable application.</a:t>
+              <a:t>independent data and</a:t>
+            </a:r>
+          </a:p>
+          <a:p xmlns:a="http://schemas.openxmlformats.org/drawingml/2006/main">
+            <a:pPr>
+              <a:defRPr sz="1800" b="0">
+                <a:solidFill>
+                  <a:srgbClr val="152B2B"/>
+                </a:solidFill>
+                <a:latin typeface="Calibri"/>
+                <a:ea typeface="Calibri"/>
+                <a:cs typeface="Calibri"/>
+              </a:defRPr>
+            </a:pPr>
+            <a:r>
+              <a:rPr sz="1800" b="0">
+                <a:solidFill>
+                  <a:srgbClr val="152B2B"/>
+                </a:solidFill>
+                <a:latin typeface="Calibri"/>
+                <a:ea typeface="Calibri"/>
+                <a:cs typeface="Calibri"/>
+              </a:rPr>
+              <a:t>reproducible evaluation.</a:t>
             </a:r>
           </a:p>
         </p:txBody>
@@ -9543,8 +9668,8 @@
         </p:nvSpPr>
         <p:spPr>
           <a:xfrm xmlns:a="http://schemas.openxmlformats.org/drawingml/2006/main">
-            <a:off x="628650" y="5953125"/>
-            <a:ext cx="10763250" cy="495300"/>
+            <a:off x="628650" y="6096000"/>
+            <a:ext cx="10477500" cy="504825"/>
           </a:xfrm>
           <a:prstGeom xmlns:a="http://schemas.openxmlformats.org/drawingml/2006/main" prst="rect">
             <a:avLst/>
@@ -9680,11 +9805,62 @@
                 <a:ea typeface="Calibri"/>
                 <a:cs typeface="Calibri"/>
               </a:rPr>
-              <a:t>One fictional display lineage, separate from held out accuracy. Training and the model method belong upstream.</a:t>
+              <a:t>Recorded model response in the current UI, not fresh inference. One fictional display lineage.</a:t>
+            </a:r>
+          </a:p>
+          <a:p xmlns:a="http://schemas.openxmlformats.org/drawingml/2006/main">
+            <a:pPr>
+              <a:defRPr sz="1575" b="0">
+                <a:solidFill>
+                  <a:srgbClr val="526464"/>
+                </a:solidFill>
+                <a:latin typeface="Calibri"/>
+                <a:ea typeface="Calibri"/>
+                <a:cs typeface="Calibri"/>
+              </a:defRPr>
+            </a:pPr>
+            <a:r>
+              <a:rPr sz="1575" b="0">
+                <a:solidFill>
+                  <a:srgbClr val="526464"/>
+                </a:solidFill>
+                <a:latin typeface="Calibri"/>
+                <a:ea typeface="Calibri"/>
+                <a:cs typeface="Calibri"/>
+              </a:rPr>
+              <a:t>Separate from held-out accuracy. Upstream authors trained the model.</a:t>
             </a:r>
           </a:p>
         </p:txBody>
       </p:sp>
+      <p:pic>
+        <p:nvPicPr>
+          <p:cNvPr id="9" name="">
+            <a:extLst xmlns:a="http://schemas.openxmlformats.org/drawingml/2006/main">
+              <a:ext uri="{FF2B5EF4-FFF2-40B4-BE49-F238E27FC236}">
+                <a16:creationId xmlns:a16="http://schemas.microsoft.com/office/drawing/2014/main" id="{4A197D1B-3399-4823-8D95-96F39E77323F}"/>
+              </a:ext>
+            </a:extLst>
+          </p:cNvPr>
+          <p:cNvPicPr>
+            <a:picLocks xmlns:a="http://schemas.openxmlformats.org/drawingml/2006/main" noChangeAspect="1"/>
+          </p:cNvPicPr>
+          <p:nvPr/>
+        </p:nvPicPr>
+        <p:blipFill>
+          <a:blip xmlns:r="http://schemas.openxmlformats.org/officeDocument/2006/relationships" xmlns:a="http://schemas.openxmlformats.org/drawingml/2006/main" r:embed="R55f9e63ab2334515"/>
+          <a:stretch xmlns:a="http://schemas.openxmlformats.org/drawingml/2006/main"/>
+        </p:blipFill>
+        <p:spPr>
+          <a:xfrm xmlns:a="http://schemas.openxmlformats.org/drawingml/2006/main">
+            <a:off x="4010025" y="1600498"/>
+            <a:ext cx="7534275" cy="4238030"/>
+          </a:xfrm>
+          <a:prstGeom xmlns:a="http://schemas.openxmlformats.org/drawingml/2006/main" prst="rect">
+            <a:avLst/>
+          </a:prstGeom>
+        </p:spPr>
+      </p:pic>
     </p:spTree>
     <p:extLst>
       <p:ext uri="{BB962C8B-B14F-4D97-AF65-F5344CB8AC3E}">
@@ -16545,8 +16721,8 @@
         </p:nvSpPr>
         <p:spPr>
           <a:xfrm xmlns:a="http://schemas.openxmlformats.org/drawingml/2006/main">
-            <a:off x="647700" y="1800225"/>
-            <a:ext cx="4762500" cy="428625"/>
+            <a:off x="647700" y="1790700"/>
+            <a:ext cx="3095625" cy="400050"/>
           </a:xfrm>
           <a:prstGeom xmlns:a="http://schemas.openxmlformats.org/drawingml/2006/main" prst="rect">
             <a:avLst/>
@@ -16562,7 +16738,7 @@
           </a:bodyPr>
           <a:lstStyle xmlns:a="http://schemas.openxmlformats.org/drawingml/2006/main">
             <a:defPPr>
-              <a:defRPr sz="2325" b="1">
+              <a:defRPr sz="2175" b="1">
                 <a:solidFill>
                   <a:srgbClr val="26766D"/>
                 </a:solidFill>
@@ -16572,7 +16748,7 @@
               </a:defRPr>
             </a:defPPr>
             <a:lvl1pPr>
-              <a:defRPr sz="2325" b="1">
+              <a:defRPr sz="2175" b="1">
                 <a:solidFill>
                   <a:srgbClr val="26766D"/>
                 </a:solidFill>
@@ -16582,7 +16758,7 @@
               </a:defRPr>
             </a:lvl1pPr>
             <a:lvl2pPr>
-              <a:defRPr sz="2325" b="1">
+              <a:defRPr sz="2175" b="1">
                 <a:solidFill>
                   <a:srgbClr val="26766D"/>
                 </a:solidFill>
@@ -16592,7 +16768,7 @@
               </a:defRPr>
             </a:lvl2pPr>
             <a:lvl3pPr>
-              <a:defRPr sz="2325" b="1">
+              <a:defRPr sz="2175" b="1">
                 <a:solidFill>
                   <a:srgbClr val="26766D"/>
                 </a:solidFill>
@@ -16602,7 +16778,7 @@
               </a:defRPr>
             </a:lvl3pPr>
             <a:lvl4pPr>
-              <a:defRPr sz="2325" b="1">
+              <a:defRPr sz="2175" b="1">
                 <a:solidFill>
                   <a:srgbClr val="26766D"/>
                 </a:solidFill>
@@ -16612,7 +16788,7 @@
               </a:defRPr>
             </a:lvl4pPr>
             <a:lvl5pPr>
-              <a:defRPr sz="2325" b="1">
+              <a:defRPr sz="2175" b="1">
                 <a:solidFill>
                   <a:srgbClr val="26766D"/>
                 </a:solidFill>
@@ -16622,7 +16798,7 @@
               </a:defRPr>
             </a:lvl5pPr>
             <a:lvl6pPr>
-              <a:defRPr sz="2325" b="1">
+              <a:defRPr sz="2175" b="1">
                 <a:solidFill>
                   <a:srgbClr val="26766D"/>
                 </a:solidFill>
@@ -16632,7 +16808,7 @@
               </a:defRPr>
             </a:lvl6pPr>
             <a:lvl7pPr>
-              <a:defRPr sz="2325" b="1">
+              <a:defRPr sz="2175" b="1">
                 <a:solidFill>
                   <a:srgbClr val="26766D"/>
                 </a:solidFill>
@@ -16642,7 +16818,7 @@
               </a:defRPr>
             </a:lvl7pPr>
             <a:lvl8pPr>
-              <a:defRPr sz="2325" b="1">
+              <a:defRPr sz="2175" b="1">
                 <a:solidFill>
                   <a:srgbClr val="26766D"/>
                 </a:solidFill>
@@ -16652,7 +16828,7 @@
               </a:defRPr>
             </a:lvl8pPr>
             <a:lvl9pPr>
-              <a:defRPr sz="2325" b="1">
+              <a:defRPr sz="2175" b="1">
                 <a:solidFill>
                   <a:srgbClr val="26766D"/>
                 </a:solidFill>
@@ -16664,7 +16840,7 @@
           </a:lstStyle>
           <a:p xmlns:a="http://schemas.openxmlformats.org/drawingml/2006/main">
             <a:pPr>
-              <a:defRPr sz="2325" b="1">
+              <a:defRPr sz="2175" b="1">
                 <a:solidFill>
                   <a:srgbClr val="26766D"/>
                 </a:solidFill>
@@ -16674,7 +16850,7 @@
               </a:defRPr>
             </a:pPr>
             <a:r>
-              <a:rPr sz="2325" b="1">
+              <a:rPr sz="2175" b="1">
                 <a:solidFill>
                   <a:srgbClr val="26766D"/>
                 </a:solidFill>
@@ -16703,8 +16879,8 @@
         </p:nvSpPr>
         <p:spPr>
           <a:xfrm xmlns:a="http://schemas.openxmlformats.org/drawingml/2006/main">
-            <a:off x="647700" y="2428875"/>
-            <a:ext cx="4905375" cy="2286000"/>
+            <a:off x="647700" y="2352675"/>
+            <a:ext cx="3095625" cy="1476375"/>
           </a:xfrm>
           <a:prstGeom xmlns:a="http://schemas.openxmlformats.org/drawingml/2006/main" prst="rect">
             <a:avLst/>
@@ -16720,7 +16896,7 @@
           </a:bodyPr>
           <a:lstStyle xmlns:a="http://schemas.openxmlformats.org/drawingml/2006/main">
             <a:defPPr>
-              <a:defRPr sz="2100" b="0">
+              <a:defRPr sz="1875" b="0">
                 <a:solidFill>
                   <a:srgbClr val="152B2B"/>
                 </a:solidFill>
@@ -16730,7 +16906,7 @@
               </a:defRPr>
             </a:defPPr>
             <a:lvl1pPr>
-              <a:defRPr sz="2100" b="0">
+              <a:defRPr sz="1875" b="0">
                 <a:solidFill>
                   <a:srgbClr val="152B2B"/>
                 </a:solidFill>
@@ -16740,7 +16916,7 @@
               </a:defRPr>
             </a:lvl1pPr>
             <a:lvl2pPr>
-              <a:defRPr sz="2100" b="0">
+              <a:defRPr sz="1875" b="0">
                 <a:solidFill>
                   <a:srgbClr val="152B2B"/>
                 </a:solidFill>
@@ -16750,7 +16926,7 @@
               </a:defRPr>
             </a:lvl2pPr>
             <a:lvl3pPr>
-              <a:defRPr sz="2100" b="0">
+              <a:defRPr sz="1875" b="0">
                 <a:solidFill>
                   <a:srgbClr val="152B2B"/>
                 </a:solidFill>
@@ -16760,7 +16936,7 @@
               </a:defRPr>
             </a:lvl3pPr>
             <a:lvl4pPr>
-              <a:defRPr sz="2100" b="0">
+              <a:defRPr sz="1875" b="0">
                 <a:solidFill>
                   <a:srgbClr val="152B2B"/>
                 </a:solidFill>
@@ -16770,7 +16946,7 @@
               </a:defRPr>
             </a:lvl4pPr>
             <a:lvl5pPr>
-              <a:defRPr sz="2100" b="0">
+              <a:defRPr sz="1875" b="0">
                 <a:solidFill>
                   <a:srgbClr val="152B2B"/>
                 </a:solidFill>
@@ -16780,7 +16956,7 @@
               </a:defRPr>
             </a:lvl5pPr>
             <a:lvl6pPr>
-              <a:defRPr sz="2100" b="0">
+              <a:defRPr sz="1875" b="0">
                 <a:solidFill>
                   <a:srgbClr val="152B2B"/>
                 </a:solidFill>
@@ -16790,7 +16966,7 @@
               </a:defRPr>
             </a:lvl6pPr>
             <a:lvl7pPr>
-              <a:defRPr sz="2100" b="0">
+              <a:defRPr sz="1875" b="0">
                 <a:solidFill>
                   <a:srgbClr val="152B2B"/>
                 </a:solidFill>
@@ -16800,7 +16976,7 @@
               </a:defRPr>
             </a:lvl7pPr>
             <a:lvl8pPr>
-              <a:defRPr sz="2100" b="0">
+              <a:defRPr sz="1875" b="0">
                 <a:solidFill>
                   <a:srgbClr val="152B2B"/>
                 </a:solidFill>
@@ -16810,7 +16986,7 @@
               </a:defRPr>
             </a:lvl8pPr>
             <a:lvl9pPr>
-              <a:defRPr sz="2100" b="0">
+              <a:defRPr sz="1875" b="0">
                 <a:solidFill>
                   <a:srgbClr val="152B2B"/>
                 </a:solidFill>
@@ -16822,7 +16998,7 @@
           </a:lstStyle>
           <a:p xmlns:a="http://schemas.openxmlformats.org/drawingml/2006/main">
             <a:pPr>
-              <a:defRPr sz="2100" b="0">
+              <a:defRPr sz="1875" b="0">
                 <a:solidFill>
                   <a:srgbClr val="152B2B"/>
                 </a:solidFill>
@@ -16832,7 +17008,7 @@
               </a:defRPr>
             </a:pPr>
             <a:r>
-              <a:rPr sz="2100" b="0">
+              <a:rPr sz="1875" b="0">
                 <a:solidFill>
                   <a:srgbClr val="152B2B"/>
                 </a:solidFill>
@@ -16840,12 +17016,12 @@
                 <a:ea typeface="Calibri"/>
                 <a:cs typeface="Calibri"/>
               </a:rPr>
-              <a:t>At most one active version per key.</a:t>
+              <a:t>One active version per key.</a:t>
             </a:r>
           </a:p>
           <a:p xmlns:a="http://schemas.openxmlformats.org/drawingml/2006/main">
             <a:pPr>
-              <a:defRPr sz="2100" b="0">
+              <a:defRPr sz="1875" b="0">
                 <a:solidFill>
                   <a:srgbClr val="152B2B"/>
                 </a:solidFill>
@@ -16855,7 +17031,7 @@
               </a:defRPr>
             </a:pPr>
             <a:r>
-              <a:rPr sz="2100" b="0">
+              <a:rPr sz="1875" b="0">
                 <a:solidFill>
                   <a:srgbClr val="152B2B"/>
                 </a:solidFill>
@@ -16863,12 +17039,12 @@
                 <a:ea typeface="Calibri"/>
                 <a:cs typeface="Calibri"/>
               </a:rPr>
-              <a:t>A replacement names its predecessor.</a:t>
+              <a:t>Named predecessor.</a:t>
             </a:r>
           </a:p>
           <a:p xmlns:a="http://schemas.openxmlformats.org/drawingml/2006/main">
             <a:pPr>
-              <a:defRPr sz="2100" b="0">
+              <a:defRPr sz="1875" b="0">
                 <a:solidFill>
                   <a:srgbClr val="152B2B"/>
                 </a:solidFill>
@@ -16878,7 +17054,7 @@
               </a:defRPr>
             </a:pPr>
             <a:r>
-              <a:rPr sz="2100" b="0">
+              <a:rPr sz="1875" b="0">
                 <a:solidFill>
                   <a:srgbClr val="152B2B"/>
                 </a:solidFill>
@@ -16886,12 +17062,12 @@
                 <a:ea typeface="Calibri"/>
                 <a:cs typeface="Calibri"/>
               </a:rPr>
-              <a:t>Competing active approval returns 409.</a:t>
+              <a:t>HTTP 409 for conflicts.</a:t>
             </a:r>
           </a:p>
           <a:p xmlns:a="http://schemas.openxmlformats.org/drawingml/2006/main">
             <a:pPr>
-              <a:defRPr sz="2100" b="0">
+              <a:defRPr sz="1875" b="0">
                 <a:solidFill>
                   <a:srgbClr val="152B2B"/>
                 </a:solidFill>
@@ -16901,7 +17077,7 @@
               </a:defRPr>
             </a:pPr>
             <a:r>
-              <a:rPr sz="2100" b="0">
+              <a:rPr sz="1875" b="0">
                 <a:solidFill>
                   <a:srgbClr val="152B2B"/>
                 </a:solidFill>
@@ -16909,7 +17085,7 @@
                 <a:ea typeface="Calibri"/>
                 <a:cs typeface="Calibri"/>
               </a:rPr>
-              <a:t>Events retain lineage and provenance.</a:t>
+              <a:t>Lineage and provenance.</a:t>
             </a:r>
           </a:p>
         </p:txBody>
@@ -16930,8 +17106,8 @@
         </p:nvSpPr>
         <p:spPr>
           <a:xfrm xmlns:a="http://schemas.openxmlformats.org/drawingml/2006/main">
-            <a:off x="6524625" y="1800225"/>
-            <a:ext cx="5000625" cy="428625"/>
+            <a:off x="647700" y="4048125"/>
+            <a:ext cx="3095625" cy="381000"/>
           </a:xfrm>
           <a:prstGeom xmlns:a="http://schemas.openxmlformats.org/drawingml/2006/main" prst="rect">
             <a:avLst/>
@@ -16947,7 +17123,7 @@
           </a:bodyPr>
           <a:lstStyle xmlns:a="http://schemas.openxmlformats.org/drawingml/2006/main">
             <a:defPPr>
-              <a:defRPr sz="2325" b="1">
+              <a:defRPr sz="2175" b="1">
                 <a:solidFill>
                   <a:srgbClr val="26766D"/>
                 </a:solidFill>
@@ -16957,7 +17133,7 @@
               </a:defRPr>
             </a:defPPr>
             <a:lvl1pPr>
-              <a:defRPr sz="2325" b="1">
+              <a:defRPr sz="2175" b="1">
                 <a:solidFill>
                   <a:srgbClr val="26766D"/>
                 </a:solidFill>
@@ -16967,7 +17143,7 @@
               </a:defRPr>
             </a:lvl1pPr>
             <a:lvl2pPr>
-              <a:defRPr sz="2325" b="1">
+              <a:defRPr sz="2175" b="1">
                 <a:solidFill>
                   <a:srgbClr val="26766D"/>
                 </a:solidFill>
@@ -16977,7 +17153,7 @@
               </a:defRPr>
             </a:lvl2pPr>
             <a:lvl3pPr>
-              <a:defRPr sz="2325" b="1">
+              <a:defRPr sz="2175" b="1">
                 <a:solidFill>
                   <a:srgbClr val="26766D"/>
                 </a:solidFill>
@@ -16987,7 +17163,7 @@
               </a:defRPr>
             </a:lvl3pPr>
             <a:lvl4pPr>
-              <a:defRPr sz="2325" b="1">
+              <a:defRPr sz="2175" b="1">
                 <a:solidFill>
                   <a:srgbClr val="26766D"/>
                 </a:solidFill>
@@ -16997,7 +17173,7 @@
               </a:defRPr>
             </a:lvl4pPr>
             <a:lvl5pPr>
-              <a:defRPr sz="2325" b="1">
+              <a:defRPr sz="2175" b="1">
                 <a:solidFill>
                   <a:srgbClr val="26766D"/>
                 </a:solidFill>
@@ -17007,7 +17183,7 @@
               </a:defRPr>
             </a:lvl5pPr>
             <a:lvl6pPr>
-              <a:defRPr sz="2325" b="1">
+              <a:defRPr sz="2175" b="1">
                 <a:solidFill>
                   <a:srgbClr val="26766D"/>
                 </a:solidFill>
@@ -17017,7 +17193,7 @@
               </a:defRPr>
             </a:lvl6pPr>
             <a:lvl7pPr>
-              <a:defRPr sz="2325" b="1">
+              <a:defRPr sz="2175" b="1">
                 <a:solidFill>
                   <a:srgbClr val="26766D"/>
                 </a:solidFill>
@@ -17027,7 +17203,7 @@
               </a:defRPr>
             </a:lvl7pPr>
             <a:lvl8pPr>
-              <a:defRPr sz="2325" b="1">
+              <a:defRPr sz="2175" b="1">
                 <a:solidFill>
                   <a:srgbClr val="26766D"/>
                 </a:solidFill>
@@ -17037,7 +17213,7 @@
               </a:defRPr>
             </a:lvl8pPr>
             <a:lvl9pPr>
-              <a:defRPr sz="2325" b="1">
+              <a:defRPr sz="2175" b="1">
                 <a:solidFill>
                   <a:srgbClr val="26766D"/>
                 </a:solidFill>
@@ -17049,7 +17225,7 @@
           </a:lstStyle>
           <a:p xmlns:a="http://schemas.openxmlformats.org/drawingml/2006/main">
             <a:pPr>
-              <a:defRPr sz="2325" b="1">
+              <a:defRPr sz="2175" b="1">
                 <a:solidFill>
                   <a:srgbClr val="26766D"/>
                 </a:solidFill>
@@ -17059,7 +17235,7 @@
               </a:defRPr>
             </a:pPr>
             <a:r>
-              <a:rPr sz="2325" b="1">
+              <a:rPr sz="2175" b="1">
                 <a:solidFill>
                   <a:srgbClr val="26766D"/>
                 </a:solidFill>
@@ -17067,7 +17243,7 @@
                 <a:ea typeface="Calibri"/>
                 <a:cs typeface="Calibri"/>
               </a:rPr>
-              <a:t>Rollback transaction</a:t>
+              <a:t>Atomic rollback</a:t>
             </a:r>
           </a:p>
         </p:txBody>
@@ -17088,8 +17264,8 @@
         </p:nvSpPr>
         <p:spPr>
           <a:xfrm xmlns:a="http://schemas.openxmlformats.org/drawingml/2006/main">
-            <a:off x="6524625" y="2428875"/>
-            <a:ext cx="5000625" cy="2286000"/>
+            <a:off x="647700" y="4552950"/>
+            <a:ext cx="3095625" cy="1266825"/>
           </a:xfrm>
           <a:prstGeom xmlns:a="http://schemas.openxmlformats.org/drawingml/2006/main" prst="rect">
             <a:avLst/>
@@ -17105,7 +17281,7 @@
           </a:bodyPr>
           <a:lstStyle xmlns:a="http://schemas.openxmlformats.org/drawingml/2006/main">
             <a:defPPr>
-              <a:defRPr sz="1950" b="0">
+              <a:defRPr sz="1575" b="0">
                 <a:solidFill>
                   <a:srgbClr val="152B2B"/>
                 </a:solidFill>
@@ -17115,7 +17291,7 @@
               </a:defRPr>
             </a:defPPr>
             <a:lvl1pPr>
-              <a:defRPr sz="1950" b="0">
+              <a:defRPr sz="1575" b="0">
                 <a:solidFill>
                   <a:srgbClr val="152B2B"/>
                 </a:solidFill>
@@ -17125,7 +17301,7 @@
               </a:defRPr>
             </a:lvl1pPr>
             <a:lvl2pPr>
-              <a:defRPr sz="1950" b="0">
+              <a:defRPr sz="1575" b="0">
                 <a:solidFill>
                   <a:srgbClr val="152B2B"/>
                 </a:solidFill>
@@ -17135,7 +17311,7 @@
               </a:defRPr>
             </a:lvl2pPr>
             <a:lvl3pPr>
-              <a:defRPr sz="1950" b="0">
+              <a:defRPr sz="1575" b="0">
                 <a:solidFill>
                   <a:srgbClr val="152B2B"/>
                 </a:solidFill>
@@ -17145,7 +17321,7 @@
               </a:defRPr>
             </a:lvl3pPr>
             <a:lvl4pPr>
-              <a:defRPr sz="1950" b="0">
+              <a:defRPr sz="1575" b="0">
                 <a:solidFill>
                   <a:srgbClr val="152B2B"/>
                 </a:solidFill>
@@ -17155,7 +17331,7 @@
               </a:defRPr>
             </a:lvl4pPr>
             <a:lvl5pPr>
-              <a:defRPr sz="1950" b="0">
+              <a:defRPr sz="1575" b="0">
                 <a:solidFill>
                   <a:srgbClr val="152B2B"/>
                 </a:solidFill>
@@ -17165,7 +17341,7 @@
               </a:defRPr>
             </a:lvl5pPr>
             <a:lvl6pPr>
-              <a:defRPr sz="1950" b="0">
+              <a:defRPr sz="1575" b="0">
                 <a:solidFill>
                   <a:srgbClr val="152B2B"/>
                 </a:solidFill>
@@ -17175,7 +17351,7 @@
               </a:defRPr>
             </a:lvl6pPr>
             <a:lvl7pPr>
-              <a:defRPr sz="1950" b="0">
+              <a:defRPr sz="1575" b="0">
                 <a:solidFill>
                   <a:srgbClr val="152B2B"/>
                 </a:solidFill>
@@ -17185,7 +17361,7 @@
               </a:defRPr>
             </a:lvl7pPr>
             <a:lvl8pPr>
-              <a:defRPr sz="1950" b="0">
+              <a:defRPr sz="1575" b="0">
                 <a:solidFill>
                   <a:srgbClr val="152B2B"/>
                 </a:solidFill>
@@ -17195,7 +17371,7 @@
               </a:defRPr>
             </a:lvl8pPr>
             <a:lvl9pPr>
-              <a:defRPr sz="1950" b="0">
+              <a:defRPr sz="1575" b="0">
                 <a:solidFill>
                   <a:srgbClr val="152B2B"/>
                 </a:solidFill>
@@ -17207,7 +17383,7 @@
           </a:lstStyle>
           <a:p xmlns:a="http://schemas.openxmlformats.org/drawingml/2006/main">
             <a:pPr>
-              <a:defRPr sz="1950" b="0">
+              <a:defRPr sz="1575" b="0">
                 <a:solidFill>
                   <a:srgbClr val="152B2B"/>
                 </a:solidFill>
@@ -17217,7 +17393,7 @@
               </a:defRPr>
             </a:pPr>
             <a:r>
-              <a:rPr sz="1950" b="0">
+              <a:rPr sz="1575" b="0">
                 <a:solidFill>
                   <a:srgbClr val="152B2B"/>
                 </a:solidFill>
@@ -17230,7 +17406,7 @@
           </a:p>
           <a:p xmlns:a="http://schemas.openxmlformats.org/drawingml/2006/main">
             <a:pPr>
-              <a:defRPr sz="1950" b="0">
+              <a:defRPr sz="1575" b="0">
                 <a:solidFill>
                   <a:srgbClr val="152B2B"/>
                 </a:solidFill>
@@ -17240,7 +17416,7 @@
               </a:defRPr>
             </a:pPr>
             <a:r>
-              <a:rPr sz="1950" b="0">
+              <a:rPr sz="1575" b="0">
                 <a:solidFill>
                   <a:srgbClr val="152B2B"/>
                 </a:solidFill>
@@ -17248,12 +17424,12 @@
                 <a:ea typeface="Consolas"/>
                 <a:cs typeface="Consolas"/>
               </a:rPr>
-              <a:t>withdraw(replacement)</a:t>
+              <a:t>withdraw(new)</a:t>
             </a:r>
           </a:p>
           <a:p xmlns:a="http://schemas.openxmlformats.org/drawingml/2006/main">
             <a:pPr>
-              <a:defRPr sz="1950" b="0">
+              <a:defRPr sz="1575" b="0">
                 <a:solidFill>
                   <a:srgbClr val="152B2B"/>
                 </a:solidFill>
@@ -17263,7 +17439,7 @@
               </a:defRPr>
             </a:pPr>
             <a:r>
-              <a:rPr sz="1950" b="0">
+              <a:rPr sz="1575" b="0">
                 <a:solidFill>
                   <a:srgbClr val="152B2B"/>
                 </a:solidFill>
@@ -17271,12 +17447,12 @@
                 <a:ea typeface="Consolas"/>
                 <a:cs typeface="Consolas"/>
               </a:rPr>
-              <a:t>restore(predecessor)</a:t>
+              <a:t>restore(previous)</a:t>
             </a:r>
           </a:p>
           <a:p xmlns:a="http://schemas.openxmlformats.org/drawingml/2006/main">
             <a:pPr>
-              <a:defRPr sz="1950" b="0">
+              <a:defRPr sz="1575" b="0">
                 <a:solidFill>
                   <a:srgbClr val="152B2B"/>
                 </a:solidFill>
@@ -17286,7 +17462,7 @@
               </a:defRPr>
             </a:pPr>
             <a:r>
-              <a:rPr sz="1950" b="0">
+              <a:rPr sz="1575" b="0">
                 <a:solidFill>
                   <a:srgbClr val="152B2B"/>
                 </a:solidFill>
@@ -17294,12 +17470,12 @@
                 <a:ea typeface="Consolas"/>
                 <a:cs typeface="Consolas"/>
               </a:rPr>
-              <a:t>record_both_events(revision)</a:t>
+              <a:t>write_events(revision)</a:t>
             </a:r>
           </a:p>
           <a:p xmlns:a="http://schemas.openxmlformats.org/drawingml/2006/main">
             <a:pPr>
-              <a:defRPr sz="1950" b="0">
+              <a:defRPr sz="1575" b="0">
                 <a:solidFill>
                   <a:srgbClr val="152B2B"/>
                 </a:solidFill>
@@ -17309,7 +17485,7 @@
               </a:defRPr>
             </a:pPr>
             <a:r>
-              <a:rPr sz="1950" b="0">
+              <a:rPr sz="1575" b="0">
                 <a:solidFill>
                   <a:srgbClr val="152B2B"/>
                 </a:solidFill>
@@ -17338,8 +17514,8 @@
         </p:nvSpPr>
         <p:spPr>
           <a:xfrm xmlns:a="http://schemas.openxmlformats.org/drawingml/2006/main">
-            <a:off x="628650" y="5953125"/>
-            <a:ext cx="10763250" cy="495300"/>
+            <a:off x="628650" y="6019800"/>
+            <a:ext cx="10477500" cy="533400"/>
           </a:xfrm>
           <a:prstGeom xmlns:a="http://schemas.openxmlformats.org/drawingml/2006/main" prst="rect">
             <a:avLst/>
@@ -17475,11 +17651,62 @@
                 <a:ea typeface="Calibri"/>
                 <a:cs typeface="Calibri"/>
               </a:rPr>
-              <a:t>Rollback pseudocode. Two audit events share one revision. Historical reads leave live memory unchanged.</a:t>
+              <a:t>Current Verity interface with a replacement draft. Approval remains explicit.</a:t>
+            </a:r>
+          </a:p>
+          <a:p xmlns:a="http://schemas.openxmlformats.org/drawingml/2006/main">
+            <a:pPr>
+              <a:defRPr sz="1575" b="0">
+                <a:solidFill>
+                  <a:srgbClr val="526464"/>
+                </a:solidFill>
+                <a:latin typeface="Calibri"/>
+                <a:ea typeface="Calibri"/>
+                <a:cs typeface="Calibri"/>
+              </a:defRPr>
+            </a:pPr>
+            <a:r>
+              <a:rPr sz="1575" b="0">
+                <a:solidFill>
+                  <a:srgbClr val="526464"/>
+                </a:solidFill>
+                <a:latin typeface="Calibri"/>
+                <a:ea typeface="Calibri"/>
+                <a:cs typeface="Calibri"/>
+              </a:rPr>
+              <a:t>Rollback writes two audit events at one revision. Historical reads leave live memory unchanged.</a:t>
             </a:r>
           </a:p>
         </p:txBody>
       </p:sp>
+      <p:pic>
+        <p:nvPicPr>
+          <p:cNvPr id="10" name="">
+            <a:extLst xmlns:a="http://schemas.openxmlformats.org/drawingml/2006/main">
+              <a:ext uri="{FF2B5EF4-FFF2-40B4-BE49-F238E27FC236}">
+                <a16:creationId xmlns:a16="http://schemas.microsoft.com/office/drawing/2014/main" id="{EDA3AE01-8FCF-47DA-A2A0-4784F4682652}"/>
+              </a:ext>
+            </a:extLst>
+          </p:cNvPr>
+          <p:cNvPicPr>
+            <a:picLocks xmlns:a="http://schemas.openxmlformats.org/drawingml/2006/main" noChangeAspect="1"/>
+          </p:cNvPicPr>
+          <p:nvPr/>
+        </p:nvPicPr>
+        <p:blipFill>
+          <a:blip xmlns:r="http://schemas.openxmlformats.org/officeDocument/2006/relationships" xmlns:a="http://schemas.openxmlformats.org/drawingml/2006/main" r:embed="Rd7772fe172934c98"/>
+          <a:stretch xmlns:a="http://schemas.openxmlformats.org/drawingml/2006/main"/>
+        </p:blipFill>
+        <p:spPr>
+          <a:xfrm xmlns:a="http://schemas.openxmlformats.org/drawingml/2006/main">
+            <a:off x="4011811" y="1600200"/>
+            <a:ext cx="7530703" cy="4238625"/>
+          </a:xfrm>
+          <a:prstGeom xmlns:a="http://schemas.openxmlformats.org/drawingml/2006/main" prst="rect">
+            <a:avLst/>
+          </a:prstGeom>
+        </p:spPr>
+      </p:pic>
     </p:spTree>
     <p:extLst>
       <p:ext uri="{BB962C8B-B14F-4D97-AF65-F5344CB8AC3E}">
@@ -20971,7 +21198,7 @@
         </p:xfrm>
         <a:graphic xmlns:a="http://schemas.openxmlformats.org/drawingml/2006/main">
           <a:graphicData uri="http://schemas.openxmlformats.org/drawingml/2006/chart">
-            <c:chart xmlns:r="http://schemas.openxmlformats.org/officeDocument/2006/relationships" xmlns:c="http://schemas.openxmlformats.org/drawingml/2006/chart" r:id="R7ed61daa0e75406f"/>
+            <c:chart xmlns:r="http://schemas.openxmlformats.org/officeDocument/2006/relationships" xmlns:c="http://schemas.openxmlformats.org/drawingml/2006/chart" r:id="Rf1afbe0e53434dae"/>
           </a:graphicData>
         </a:graphic>
       </p:graphicFrame>

</xml_diff>